<commit_message>
made some improvs to ocr and made the lite weight poc for prod
</commit_message>
<xml_diff>
--- a/deliverables/SENTINEL_Presentation.pptx
+++ b/deliverables/SENTINEL_Presentation.pptx
@@ -3389,7 +3389,7 @@
                 </a:solidFill>
                 <a:latin typeface="Arial"/>
               </a:rPr>
-              <a:t>Divij Patel — Individual participant, Category 1  ·  vatsunp11@gmail.com</a:t>
+              <a:t>Divij Patel, Meet Patel, Krish Patel — Team, Category 1  ·  vatsunp11@gmail.com</a:t>
             </a:r>
           </a:p>
         </p:txBody>
@@ -3865,7 +3865,7 @@
                 </a:solidFill>
                 <a:latin typeface="Arial"/>
               </a:rPr>
-              <a:t>SENTINEL — Divij Patel (Individual, Category 1) — Gujarat Police CCTV Hackathon 2026</a:t>
+              <a:t>SENTINEL — Divij Patel · Meet Patel · Krish Patel — Gujarat Police CCTV Hackathon 2026</a:t>
             </a:r>
           </a:p>
         </p:txBody>
@@ -4651,7 +4651,7 @@
                 </a:solidFill>
                 <a:latin typeface="Arial"/>
               </a:rPr>
-              <a:t>SENTINEL — Divij Patel (Individual, Category 1) — Gujarat Police CCTV Hackathon 2026</a:t>
+              <a:t>SENTINEL — Divij Patel · Meet Patel · Krish Patel — Gujarat Police CCTV Hackathon 2026</a:t>
             </a:r>
           </a:p>
         </p:txBody>
@@ -6697,7 +6697,7 @@
                 </a:solidFill>
                 <a:latin typeface="Arial"/>
               </a:rPr>
-              <a:t>SENTINEL — Divij Patel (Individual, Category 1) — Gujarat Police CCTV Hackathon 2026</a:t>
+              <a:t>SENTINEL — Divij Patel · Meet Patel · Krish Patel — Gujarat Police CCTV Hackathon 2026</a:t>
             </a:r>
           </a:p>
         </p:txBody>
@@ -7453,7 +7453,7 @@
                 </a:solidFill>
                 <a:latin typeface="Arial"/>
               </a:rPr>
-              <a:t>SENTINEL  ·  Hybrid Model 1 + 2/4  ·  Divij Patel (Individual, Category 1)  ·  Gujarat Police CCTV Hackathon 2026</a:t>
+              <a:t>SENTINEL  ·  Hybrid Model 1 + 2/4  ·  Divij Patel · Meet Patel · Krish Patel  ·  Gujarat Police CCTV Hackathon 2026</a:t>
             </a:r>
           </a:p>
         </p:txBody>
@@ -7514,7 +7514,7 @@
                 </a:solidFill>
                 <a:latin typeface="Arial"/>
               </a:rPr>
-              <a:t>SENTINEL — Divij Patel (Individual, Category 1) — Gujarat Police CCTV Hackathon 2026</a:t>
+              <a:t>SENTINEL — Divij Patel · Meet Patel · Krish Patel — Gujarat Police CCTV Hackathon 2026</a:t>
             </a:r>
           </a:p>
         </p:txBody>
@@ -8620,7 +8620,7 @@
                 </a:solidFill>
                 <a:latin typeface="Arial"/>
               </a:rPr>
-              <a:t>SENTINEL — Divij Patel (Individual, Category 1) — Gujarat Police CCTV Hackathon 2026</a:t>
+              <a:t>SENTINEL — Divij Patel · Meet Patel · Krish Patel — Gujarat Police CCTV Hackathon 2026</a:t>
             </a:r>
           </a:p>
         </p:txBody>
@@ -9645,7 +9645,7 @@
                 </a:solidFill>
                 <a:latin typeface="Arial"/>
               </a:rPr>
-              <a:t>SENTINEL — Divij Patel (Individual, Category 1) — Gujarat Police CCTV Hackathon 2026</a:t>
+              <a:t>SENTINEL — Divij Patel · Meet Patel · Krish Patel — Gujarat Police CCTV Hackathon 2026</a:t>
             </a:r>
           </a:p>
         </p:txBody>
@@ -10274,7 +10274,7 @@
                 </a:solidFill>
                 <a:latin typeface="Arial"/>
               </a:rPr>
-              <a:t>SENTINEL — Divij Patel (Individual, Category 1) — Gujarat Police CCTV Hackathon 2026</a:t>
+              <a:t>SENTINEL — Divij Patel · Meet Patel · Krish Patel — Gujarat Police CCTV Hackathon 2026</a:t>
             </a:r>
           </a:p>
         </p:txBody>
@@ -11452,7 +11452,7 @@
                 </a:solidFill>
                 <a:latin typeface="Arial"/>
               </a:rPr>
-              <a:t>SENTINEL — Divij Patel (Individual, Category 1) — Gujarat Police CCTV Hackathon 2026</a:t>
+              <a:t>SENTINEL — Divij Patel · Meet Patel · Krish Patel — Gujarat Police CCTV Hackathon 2026</a:t>
             </a:r>
           </a:p>
         </p:txBody>
@@ -12295,7 +12295,7 @@
                 </a:solidFill>
                 <a:latin typeface="Arial"/>
               </a:rPr>
-              <a:t>SENTINEL — Divij Patel (Individual, Category 1) — Gujarat Police CCTV Hackathon 2026</a:t>
+              <a:t>SENTINEL — Divij Patel · Meet Patel · Krish Patel — Gujarat Police CCTV Hackathon 2026</a:t>
             </a:r>
           </a:p>
         </p:txBody>
@@ -13747,7 +13747,7 @@
                 </a:solidFill>
                 <a:latin typeface="Arial"/>
               </a:rPr>
-              <a:t>SENTINEL — Divij Patel (Individual, Category 1) — Gujarat Police CCTV Hackathon 2026</a:t>
+              <a:t>SENTINEL — Divij Patel · Meet Patel · Krish Patel — Gujarat Police CCTV Hackathon 2026</a:t>
             </a:r>
           </a:p>
         </p:txBody>
@@ -14258,7 +14258,7 @@
                 </a:solidFill>
                 <a:latin typeface="Arial"/>
               </a:rPr>
-              <a:t>SENTINEL — Divij Patel (Individual, Category 1) — Gujarat Police CCTV Hackathon 2026</a:t>
+              <a:t>SENTINEL — Divij Patel · Meet Patel · Krish Patel — Gujarat Police CCTV Hackathon 2026</a:t>
             </a:r>
           </a:p>
         </p:txBody>

</xml_diff>

<commit_message>
feat: live video anpr studio, overnight 13m cycler, camera stability, and daytime footage integration
</commit_message>
<xml_diff>
--- a/deliverables/SENTINEL_Presentation.pptx
+++ b/deliverables/SENTINEL_Presentation.pptx
@@ -579,7 +579,7 @@
           <a:lstStyle/>
           <a:p>
             <a:r>
-              <a:t>WHAT IT DOES (~60s). The whole platform in five steps. ONE register &amp; view — every department's cameras onboard from a live catalogue onto one GIS map; heterogeneous feeds in one pane, nothing hard-coded. TWO detect — CPU-only ANPR reads plates off the live feed, each read timestamped with a confidence. THREE correlate &amp; alert — every read checked against the watchlist; a match fires a real-time alert in under a second with the camera's own frame. FOUR trace — search a plate, the timestamped route draws camera-by-camera with a physics filter rejecting impossible hops. FIVE prove — one click exports a hash-sealed chain-of-custody dossier.</a:t>
+              <a:t>WHAT IT DOES (~60s). Five steps. ONE register &amp; view — every department's cameras onboard from a live catalogue onto one GIS map, with metadata, health, CSV import/export, and a gap analysis that flags coverage blind-spots; live viewing of heterogeneous feeds, nothing hard-coded. TWO detect — CPU-only ANPR reads plates, each timestamped with a confidence. THREE correlate &amp; alert — every read checked against the watchlist; a match fires a real-time alert under a second with the camera's own frame. FOUR trace — search a plate, the timestamped route draws camera-by-camera with a physics filter. FIVE prove — one click exports a hash-sealed chain-of-custody dossier.</a:t>
             </a:r>
           </a:p>
         </p:txBody>
@@ -649,7 +649,7 @@
           <a:lstStyle/>
           <a:p>
             <a:r>
-              <a:t>PROBLEMS SOLVED (~60s). The real pains and our answers. 26 departments, siloed incompatible CCTV — one catalogue-driven registry, we integrate, never rip-and-replace. Days of manual search — plate in, route out in seconds. OCR misreads on real CCTV — recovered by a deterministic grammar-aware engine we call 'the king', always with a shown confidence. Evidence that dies before court — a SHA-256 hash-chained dossier. Insider tampering — an append-only hash-chained audit log; any edit breaks the chain. Scaling to 80,000 cameras — video stays at the edge, only 1-3 Kbps of metadata travels upstream.</a:t>
+              <a:t>PROBLEMS SOLVED (~60s). Real pains, our answers. Fragmented, incompatible CCTV across 26 departments — one catalogue-driven registry, integrate not replace, mixed codecs handled. No view of where coverage is missing — a gap analysis flags under-covered districts and areas, with an exportable report. Days of manual search — plate in, route out in seconds. OCR misreads — recovered by the deterministic 'king' with shown confidence. Evidence that dies in court — a SHA-256 hash-chained dossier. Insider tampering — a hash-chained audit log; any edit breaks the chain. Scaling to 80,000 — video stays at the edge, only metadata upstream.</a:t>
             </a:r>
           </a:p>
         </p:txBody>
@@ -719,7 +719,7 @@
           <a:lstStyle/>
           <a:p>
             <a:r>
-              <a:t>TECH STACK (~45s). Entirely open-source, CPU-only, no vendor lock, no GPU dependency — which matters for Make-in-India. React + Leaflet front end; FastAPI + PostgreSQL back end. ANPR: YOLOv8n vehicles, a plate localizer, RapidOCR with an Indian plate-syntax gate, and the king on top. Streaming is RTSP over TCP, PTS-anchored. For scale: Docker, Kubernetes, a Kafka event bus (Redpanda), and S3 object storage (SeaweedFS). Every piece is free and replaceable.</a:t>
+              <a:t>TECH STACK (~45s). Entirely open-source, CPU-only, no vendor lock, no GPU dependency — Make-in-India friendly. React + Leaflet front end; FastAPI + PostgreSQL back end, with the camera registry, gap analysis and CSV export. ANPR: YOLOv8n, a plate localizer, RapidOCR + Indian syntax gate, and the king. Streaming is RTSP over TCP, PTS-anchored. For scale: Docker, Kubernetes, a Kafka event bus (Redpanda), S3 object storage (SeaweedFS). Every piece free and replaceable.</a:t>
             </a:r>
           </a:p>
         </p:txBody>
@@ -789,7 +789,7 @@
           <a:lstStyle/>
           <a:p>
             <a:r>
-              <a:t>RESULTS (~60s). All measured, not asserted. Onboarded all 30 government cameras live. OCR went from 1 correct read in 19 to 11, and the king recovered the true plate on 6 of 6 of the hardest cases. Alerts under a second. On production components we proved: Postgres replication at 16 ms for DR; one Kafka broker at 15,600 events/s — forty times the whole state's load; object storage at the state's full snapshot rate. Evidence is tamper-evident; the scale arithmetic is computed — 150 TB of snapshots instead of 52 petabytes of video.</a:t>
+              <a:t>RESULTS (~60s). All measured. 30 government cameras onboarded live; the gap analysis maps them across 7 of 33 districts. OCR went from 1 correct read in 19 to 11, and the king recovered the true plate on 6 of 6 of the hardest cases. Alerts under a second. Production components proved: Postgres replication at 16 ms for DR; one Kafka broker at 15,600 events/s — 40x the state's load; object storage at the state's full snapshot rate. Tamper-evident evidence; computed scale — 150 TB of snapshots not 52 petabytes of video. 18 backend tests pass.</a:t>
             </a:r>
           </a:p>
         </p:txBody>
@@ -859,7 +859,7 @@
           <a:lstStyle/>
           <a:p>
             <a:r>
-              <a:t>WHAT WE ACHIEVED (~45s). Every mandatory module, working and verified on live feeds. Evidence-first by design — never asserts a read as fact; shows confidence, recovers misreads, explains every result via TrustTrace. We added the king for deterministic reconciliation, moved to PostgreSQL in a one-command Docker stack, and proved the production topology with real numbers. Honest and affordable — CPU-only, open-source, ~₹15-20 crore for the whole state, zero new cameras.</a:t>
+              <a:t>WHAT WE ACHIEVED (~45s). Every mandatory module built and verified on live feeds — including a full Model 1 registry with metadata, gap analysis, CSV and department scope. Evidence-first by design — never asserts a read as fact; shows confidence, recovers misreads, explains via TrustTrace. We added the king for deterministic reconciliation, moved to PostgreSQL in a one-command Docker stack, and proved the production topology with real numbers. Honest and affordable — CPU-only, open-source, ~₹15-20 crore statewide, zero new cameras.</a:t>
             </a:r>
           </a:p>
         </p:txBody>
@@ -4785,7 +4785,7 @@
                 </a:solidFill>
                 <a:latin typeface="Arial"/>
               </a:rPr>
-              <a:t>Catalogue-driven registry + GIS map of every department's cameras; live viewing of heterogeneous feeds — nothing hard-coded, nothing replaced.</a:t>
+              <a:t>Catalogue-driven registry + GIS map of every department's cameras — metadata, health, CSV import/export, and a gap analysis that flags coverage blind-spots. Live viewing of heterogeneous feeds; nothing hard-coded, nothing replaced.</a:t>
             </a:r>
           </a:p>
         </p:txBody>
@@ -5577,7 +5577,7 @@
                 </a:solidFill>
                 <a:latin typeface="Arial"/>
               </a:rPr>
-              <a:t>Fragmented CCTV across 26 departments</a:t>
+              <a:t>Fragmented, incompatible CCTV (26 depts)</a:t>
             </a:r>
           </a:p>
         </p:txBody>
@@ -5625,7 +5625,7 @@
                 </a:solidFill>
                 <a:latin typeface="Arial"/>
               </a:rPr>
-              <a:t>One catalogue-driven registry + GIS; integrate, don't rip-and-replace.</a:t>
+              <a:t>One catalogue-driven registry + GIS; integrate don't replace; mixed H.264/H.265 and vendors handled per-camera.</a:t>
             </a:r>
           </a:p>
         </p:txBody>
@@ -5717,7 +5717,7 @@
                 </a:solidFill>
                 <a:latin typeface="Arial"/>
               </a:rPr>
-              <a:t>Incompatible vendors, codecs, resolutions</a:t>
+              <a:t>No view of where coverage is missing</a:t>
             </a:r>
           </a:p>
         </p:txBody>
@@ -5765,7 +5765,7 @@
                 </a:solidFill>
                 <a:latin typeface="Arial"/>
               </a:rPr>
-              <a:t>Per-camera properties from the catalogue; mixed H.264/H.265 handled; adapter pattern.</a:t>
+              <a:t>A gap analysis flags districts and areas with inadequate CCTV — with an exportable report for planning.</a:t>
             </a:r>
           </a:p>
         </p:txBody>
@@ -7290,7 +7290,7 @@
                 </a:solidFill>
                 <a:latin typeface="Arial"/>
               </a:rPr>
-              <a:t>Data</a:t>
+              <a:t>Data &amp; registry</a:t>
             </a:r>
           </a:p>
           <a:p>
@@ -7346,7 +7346,7 @@
                 </a:solidFill>
                 <a:latin typeface="Arial"/>
               </a:rPr>
-              <a:t>SQLite (dev) — DB-agnostic</a:t>
+              <a:t>Camera registry + gap analysis</a:t>
             </a:r>
           </a:p>
           <a:p>
@@ -7374,7 +7374,7 @@
                 </a:solidFill>
                 <a:latin typeface="Arial"/>
               </a:rPr>
-              <a:t>Hash-chained audit log</a:t>
+              <a:t>CSV import/export · dept scope</a:t>
             </a:r>
           </a:p>
           <a:p>
@@ -7402,7 +7402,7 @@
                 </a:solidFill>
                 <a:latin typeface="Arial"/>
               </a:rPr>
-              <a:t>SHA-256 chain-of-custody</a:t>
+              <a:t>Hash-chained audit · SHA-256 dossier</a:t>
             </a:r>
           </a:p>
         </p:txBody>
@@ -9449,7 +9449,7 @@
                 </a:solidFill>
                 <a:latin typeface="Arial"/>
               </a:rPr>
-              <a:t>Scale arithmetic (computed)</a:t>
+              <a:t>Registry &amp; scale (computed)</a:t>
             </a:r>
           </a:p>
           <a:p>
@@ -9477,7 +9477,7 @@
                 </a:solidFill>
                 <a:latin typeface="Arial"/>
               </a:rPr>
-              <a:t>Video stays at the edge: ~1–3 Kbps metadata/camera upstream</a:t>
+              <a:t>Gap analysis: 30 cameras mapped across 7 of 33 districts</a:t>
             </a:r>
           </a:p>
           <a:p>
@@ -9505,7 +9505,7 @@
                 </a:solidFill>
                 <a:latin typeface="Arial"/>
               </a:rPr>
-              <a:t>160 Gbps of video → ~80–240 Mbps of events statewide</a:t>
+              <a:t>Edge-first: 160 Gbps video → ~80–240 Mbps events statewide</a:t>
             </a:r>
           </a:p>
           <a:p>
@@ -9561,7 +9561,7 @@
                 </a:solidFill>
                 <a:latin typeface="Arial"/>
               </a:rPr>
-              <a:t>12 backend tests passing; full Docker stack on PostgreSQL</a:t>
+              <a:t>18 backend tests passing; full Docker stack on PostgreSQL</a:t>
             </a:r>
           </a:p>
         </p:txBody>
@@ -9912,7 +9912,7 @@
                 </a:solidFill>
                 <a:latin typeface="Arial"/>
               </a:rPr>
-              <a:t>Registry · GIS · viewing · ANPR · watchlist · alerts</a:t>
+              <a:t>Model 1 registry: metadata · gap analysis · CSV · dept scope</a:t>
             </a:r>
           </a:p>
           <a:p>
@@ -9940,7 +9940,7 @@
                 </a:solidFill>
                 <a:latin typeface="Arial"/>
               </a:rPr>
-              <a:t>Route reconstruction + physics filter + dossier</a:t>
+              <a:t>ANPR · watchlist · alerts · route + physics · dossier</a:t>
             </a:r>
           </a:p>
           <a:p>
@@ -9968,7 +9968,7 @@
                 </a:solidFill>
                 <a:latin typeface="Arial"/>
               </a:rPr>
-              <a:t>12 backend tests pass; clean-clone quickstart</a:t>
+              <a:t>18 backend tests pass; clean-clone quickstart</a:t>
             </a:r>
           </a:p>
         </p:txBody>

</xml_diff>